<commit_message>
auto: Cowork/CLI 동기화 2026-07-16 18:05
</commit_message>
<xml_diff>
--- a/63_youtube_creator/pipeline/output/crisp_dm_shorts.pptx
+++ b/63_youtube_creator/pipeline/output/crisp_dm_shorts.pptx
@@ -3262,8 +3262,8 @@
         </p:nvSpPr>
         <p:spPr>
           <a:xfrm>
-            <a:off x="457200" y="2743200"/>
-            <a:ext cx="7315200" cy="9144000"/>
+            <a:off x="457200" y="1371600"/>
+            <a:ext cx="7315200" cy="11887200"/>
           </a:xfrm>
           <a:prstGeom prst="rect">
             <a:avLst/>
@@ -3277,7 +3277,7 @@
           <a:lstStyle/>
           <a:p>
             <a:r>
-              <a:rPr sz="5500" b="1">
+              <a:rPr sz="6000" b="1">
                 <a:solidFill>
                   <a:srgbClr val="00F0FF"/>
                 </a:solidFill>
@@ -3289,7 +3289,7 @@
           </a:p>
           <a:p>
             <a:r>
-              <a:rPr sz="3500" b="1">
+              <a:rPr sz="3200" b="1">
                 <a:solidFill>
                   <a:srgbClr val="00F0FF"/>
                 </a:solidFill>
@@ -3298,31 +3298,29 @@
               <a:t>Step 1 </a:t>
             </a:r>
             <a:r>
-              <a:rPr sz="3500" b="1">
+              <a:rPr sz="3200" b="1">
                 <a:solidFill>
                   <a:srgbClr val="FFFFFF"/>
                 </a:solidFill>
                 <a:latin typeface="Malgun Gothic"/>
               </a:rPr>
-              <a:t>Business Understanding
-</a:t>
-            </a:r>
-          </a:p>
-          <a:p>
-            <a:r>
-              <a:rPr sz="3000" b="0">
+              <a:t>Business Understanding</a:t>
+            </a:r>
+          </a:p>
+          <a:p>
+            <a:r>
+              <a:rPr sz="2800" b="0">
                 <a:solidFill>
                   <a:srgbClr val="39FF14"/>
                 </a:solidFill>
                 <a:latin typeface="Malgun Gothic"/>
               </a:rPr>
-              <a:t>  → 비즈니스 목표 정의
-</a:t>
-            </a:r>
-          </a:p>
-          <a:p>
-            <a:r>
-              <a:rPr sz="3500" b="1">
+              <a:t>  → 비즈니스 목표 정의</a:t>
+            </a:r>
+          </a:p>
+          <a:p>
+            <a:r>
+              <a:rPr sz="3200" b="1">
                 <a:solidFill>
                   <a:srgbClr val="00F0FF"/>
                 </a:solidFill>
@@ -3331,31 +3329,29 @@
               <a:t>Step 2 </a:t>
             </a:r>
             <a:r>
-              <a:rPr sz="3500" b="1">
+              <a:rPr sz="3200" b="1">
                 <a:solidFill>
                   <a:srgbClr val="FFFFFF"/>
                 </a:solidFill>
                 <a:latin typeface="Malgun Gothic"/>
               </a:rPr>
-              <a:t>Data Understanding
-</a:t>
-            </a:r>
-          </a:p>
-          <a:p>
-            <a:r>
-              <a:rPr sz="3000" b="0">
+              <a:t>Data Understanding</a:t>
+            </a:r>
+          </a:p>
+          <a:p>
+            <a:r>
+              <a:rPr sz="2800" b="0">
                 <a:solidFill>
                   <a:srgbClr val="39FF14"/>
                 </a:solidFill>
                 <a:latin typeface="Malgun Gothic"/>
               </a:rPr>
-              <a:t>  → 데이터 수집 및 탐색
-</a:t>
-            </a:r>
-          </a:p>
-          <a:p>
-            <a:r>
-              <a:rPr sz="3500" b="1">
+              <a:t>  → 데이터 수집 및 탐색</a:t>
+            </a:r>
+          </a:p>
+          <a:p>
+            <a:r>
+              <a:rPr sz="3200" b="1">
                 <a:solidFill>
                   <a:srgbClr val="00F0FF"/>
                 </a:solidFill>
@@ -3364,31 +3360,29 @@
               <a:t>Step 3 </a:t>
             </a:r>
             <a:r>
-              <a:rPr sz="3500" b="1">
+              <a:rPr sz="3200" b="1">
                 <a:solidFill>
                   <a:srgbClr val="FFFFFF"/>
                 </a:solidFill>
                 <a:latin typeface="Malgun Gothic"/>
               </a:rPr>
-              <a:t>Data Preparation
-</a:t>
-            </a:r>
-          </a:p>
-          <a:p>
-            <a:r>
-              <a:rPr sz="3000" b="0">
+              <a:t>Data Preparation</a:t>
+            </a:r>
+          </a:p>
+          <a:p>
+            <a:r>
+              <a:rPr sz="2800" b="0">
                 <a:solidFill>
                   <a:srgbClr val="39FF14"/>
                 </a:solidFill>
                 <a:latin typeface="Malgun Gothic"/>
               </a:rPr>
-              <a:t>  → 데이터 정제 및 전처리
-</a:t>
-            </a:r>
-          </a:p>
-          <a:p>
-            <a:r>
-              <a:rPr sz="3500" b="1">
+              <a:t>  → 데이터 정제 및 전처리</a:t>
+            </a:r>
+          </a:p>
+          <a:p>
+            <a:r>
+              <a:rPr sz="3200" b="1">
                 <a:solidFill>
                   <a:srgbClr val="00F0FF"/>
                 </a:solidFill>
@@ -3397,31 +3391,29 @@
               <a:t>Step 4 </a:t>
             </a:r>
             <a:r>
-              <a:rPr sz="3500" b="1">
+              <a:rPr sz="3200" b="1">
                 <a:solidFill>
                   <a:srgbClr val="FFFFFF"/>
                 </a:solidFill>
                 <a:latin typeface="Malgun Gothic"/>
               </a:rPr>
-              <a:t>Modeling
-</a:t>
-            </a:r>
-          </a:p>
-          <a:p>
-            <a:r>
-              <a:rPr sz="3000" b="0">
+              <a:t>Modeling</a:t>
+            </a:r>
+          </a:p>
+          <a:p>
+            <a:r>
+              <a:rPr sz="2800" b="0">
                 <a:solidFill>
                   <a:srgbClr val="39FF14"/>
                 </a:solidFill>
                 <a:latin typeface="Malgun Gothic"/>
               </a:rPr>
-              <a:t>  → 알고리즘 학습 및 튜닝
-</a:t>
-            </a:r>
-          </a:p>
-          <a:p>
-            <a:r>
-              <a:rPr sz="3500" b="1">
+              <a:t>  → 알고리즘 학습 및 튜닝</a:t>
+            </a:r>
+          </a:p>
+          <a:p>
+            <a:r>
+              <a:rPr sz="3200" b="1">
                 <a:solidFill>
                   <a:srgbClr val="00F0FF"/>
                 </a:solidFill>
@@ -3430,31 +3422,29 @@
               <a:t>Step 5 </a:t>
             </a:r>
             <a:r>
-              <a:rPr sz="3500" b="1">
+              <a:rPr sz="3200" b="1">
                 <a:solidFill>
                   <a:srgbClr val="FFFFFF"/>
                 </a:solidFill>
                 <a:latin typeface="Malgun Gothic"/>
               </a:rPr>
-              <a:t>Evaluation
-</a:t>
-            </a:r>
-          </a:p>
-          <a:p>
-            <a:r>
-              <a:rPr sz="3000" b="0">
+              <a:t>Evaluation</a:t>
+            </a:r>
+          </a:p>
+          <a:p>
+            <a:r>
+              <a:rPr sz="2800" b="0">
                 <a:solidFill>
                   <a:srgbClr val="39FF14"/>
                 </a:solidFill>
                 <a:latin typeface="Malgun Gothic"/>
               </a:rPr>
-              <a:t>  → 성능 검증
-</a:t>
-            </a:r>
-          </a:p>
-          <a:p>
-            <a:r>
-              <a:rPr sz="3500" b="1">
+              <a:t>  → 성능 검증</a:t>
+            </a:r>
+          </a:p>
+          <a:p>
+            <a:r>
+              <a:rPr sz="3200" b="1">
                 <a:solidFill>
                   <a:srgbClr val="00F0FF"/>
                 </a:solidFill>
@@ -3463,26 +3453,24 @@
               <a:t>Step 6 </a:t>
             </a:r>
             <a:r>
-              <a:rPr sz="3500" b="1">
+              <a:rPr sz="3200" b="1">
                 <a:solidFill>
                   <a:srgbClr val="FFFFFF"/>
                 </a:solidFill>
                 <a:latin typeface="Malgun Gothic"/>
               </a:rPr>
-              <a:t>Deployment
-</a:t>
-            </a:r>
-          </a:p>
-          <a:p>
-            <a:r>
-              <a:rPr sz="3000" b="0">
+              <a:t>Deployment</a:t>
+            </a:r>
+          </a:p>
+          <a:p>
+            <a:r>
+              <a:rPr sz="2800" b="0">
                 <a:solidFill>
                   <a:srgbClr val="39FF14"/>
                 </a:solidFill>
                 <a:latin typeface="Malgun Gothic"/>
               </a:rPr>
-              <a:t>  → 운영 환경 적용
-</a:t>
+              <a:t>  → 운영 환경 적용</a:t>
             </a:r>
           </a:p>
         </p:txBody>

</xml_diff>

<commit_message>
auto: Cowork/CLI 동기화 2026-07-16 18:21
</commit_message>
<xml_diff>
--- a/63_youtube_creator/pipeline/output/crisp_dm_shorts.pptx
+++ b/63_youtube_creator/pipeline/output/crisp_dm_shorts.pptx
@@ -3124,7 +3124,7 @@
           <a:p>
             <a:pPr algn="ctr"/>
             <a:r>
-              <a:rPr sz="7000" b="1">
+              <a:rPr sz="6600" b="1">
                 <a:solidFill>
                   <a:srgbClr val="00F0FF"/>
                 </a:solidFill>
@@ -3134,7 +3134,7 @@
 </a:t>
             </a:r>
             <a:r>
-              <a:rPr sz="4500" b="1">
+              <a:rPr sz="4100" b="1">
                 <a:solidFill>
                   <a:srgbClr val="FFFFFF"/>
                 </a:solidFill>
@@ -3207,7 +3207,7 @@
 </a:t>
             </a:r>
             <a:r>
-              <a:rPr sz="5000" b="1">
+              <a:rPr sz="4600" b="1">
                 <a:solidFill>
                   <a:srgbClr val="00F0FF"/>
                 </a:solidFill>
@@ -3277,7 +3277,7 @@
           <a:lstStyle/>
           <a:p>
             <a:r>
-              <a:rPr sz="6000" b="1">
+              <a:rPr sz="5600" b="1">
                 <a:solidFill>
                   <a:srgbClr val="00F0FF"/>
                 </a:solidFill>
@@ -3289,7 +3289,7 @@
           </a:p>
           <a:p>
             <a:r>
-              <a:rPr sz="3200" b="1">
+              <a:rPr sz="2800" b="1">
                 <a:solidFill>
                   <a:srgbClr val="00F0FF"/>
                 </a:solidFill>
@@ -3298,7 +3298,7 @@
               <a:t>Step 1 </a:t>
             </a:r>
             <a:r>
-              <a:rPr sz="3200" b="1">
+              <a:rPr sz="2800" b="1">
                 <a:solidFill>
                   <a:srgbClr val="FFFFFF"/>
                 </a:solidFill>
@@ -3320,7 +3320,7 @@
           </a:p>
           <a:p>
             <a:r>
-              <a:rPr sz="3200" b="1">
+              <a:rPr sz="2800" b="1">
                 <a:solidFill>
                   <a:srgbClr val="00F0FF"/>
                 </a:solidFill>
@@ -3329,7 +3329,7 @@
               <a:t>Step 2 </a:t>
             </a:r>
             <a:r>
-              <a:rPr sz="3200" b="1">
+              <a:rPr sz="2800" b="1">
                 <a:solidFill>
                   <a:srgbClr val="FFFFFF"/>
                 </a:solidFill>
@@ -3351,7 +3351,7 @@
           </a:p>
           <a:p>
             <a:r>
-              <a:rPr sz="3200" b="1">
+              <a:rPr sz="2800" b="1">
                 <a:solidFill>
                   <a:srgbClr val="00F0FF"/>
                 </a:solidFill>
@@ -3360,7 +3360,7 @@
               <a:t>Step 3 </a:t>
             </a:r>
             <a:r>
-              <a:rPr sz="3200" b="1">
+              <a:rPr sz="2800" b="1">
                 <a:solidFill>
                   <a:srgbClr val="FFFFFF"/>
                 </a:solidFill>
@@ -3382,7 +3382,7 @@
           </a:p>
           <a:p>
             <a:r>
-              <a:rPr sz="3200" b="1">
+              <a:rPr sz="2800" b="1">
                 <a:solidFill>
                   <a:srgbClr val="00F0FF"/>
                 </a:solidFill>
@@ -3391,7 +3391,7 @@
               <a:t>Step 4 </a:t>
             </a:r>
             <a:r>
-              <a:rPr sz="3200" b="1">
+              <a:rPr sz="2800" b="1">
                 <a:solidFill>
                   <a:srgbClr val="FFFFFF"/>
                 </a:solidFill>
@@ -3413,7 +3413,7 @@
           </a:p>
           <a:p>
             <a:r>
-              <a:rPr sz="3200" b="1">
+              <a:rPr sz="2800" b="1">
                 <a:solidFill>
                   <a:srgbClr val="00F0FF"/>
                 </a:solidFill>
@@ -3422,7 +3422,7 @@
               <a:t>Step 5 </a:t>
             </a:r>
             <a:r>
-              <a:rPr sz="3200" b="1">
+              <a:rPr sz="2800" b="1">
                 <a:solidFill>
                   <a:srgbClr val="FFFFFF"/>
                 </a:solidFill>
@@ -3444,7 +3444,7 @@
           </a:p>
           <a:p>
             <a:r>
-              <a:rPr sz="3200" b="1">
+              <a:rPr sz="2800" b="1">
                 <a:solidFill>
                   <a:srgbClr val="00F0FF"/>
                 </a:solidFill>
@@ -3453,7 +3453,7 @@
               <a:t>Step 6 </a:t>
             </a:r>
             <a:r>
-              <a:rPr sz="3200" b="1">
+              <a:rPr sz="2800" b="1">
                 <a:solidFill>
                   <a:srgbClr val="FFFFFF"/>
                 </a:solidFill>
@@ -3525,7 +3525,7 @@
           <a:p>
             <a:pPr algn="ctr"/>
             <a:r>
-              <a:rPr sz="4500" b="1">
+              <a:rPr sz="4100" b="1">
                 <a:solidFill>
                   <a:srgbClr val="00F0FF"/>
                 </a:solidFill>
@@ -3565,7 +3565,7 @@
           <a:p>
             <a:pPr algn="ctr"/>
             <a:r>
-              <a:rPr sz="3200" b="1">
+              <a:rPr sz="2800" b="1">
                 <a:solidFill>
                   <a:srgbClr val="39FF14"/>
                 </a:solidFill>
@@ -3575,7 +3575,7 @@
 </a:t>
             </a:r>
             <a:r>
-              <a:rPr sz="4000" b="1">
+              <a:rPr sz="3600" b="1">
                 <a:solidFill>
                   <a:srgbClr val="00F0FF"/>
                 </a:solidFill>
@@ -3636,7 +3636,7 @@
           <a:p>
             <a:pPr algn="ctr"/>
             <a:r>
-              <a:rPr sz="5000" b="1">
+              <a:rPr sz="4600" b="1">
                 <a:solidFill>
                   <a:srgbClr val="FFFFFF"/>
                 </a:solidFill>
@@ -3648,7 +3648,7 @@
 </a:t>
             </a:r>
             <a:r>
-              <a:rPr sz="4500" b="1">
+              <a:rPr sz="4100" b="1">
                 <a:solidFill>
                   <a:srgbClr val="39FF14"/>
                 </a:solidFill>

</xml_diff>

<commit_message>
auto: Cowork/CLI 동기화 2026-07-16 18:33
</commit_message>
<xml_diff>
--- a/63_youtube_creator/pipeline/output/crisp_dm_shorts.pptx
+++ b/63_youtube_creator/pipeline/output/crisp_dm_shorts.pptx
@@ -11,7 +11,7 @@
     <p:sldId id="259" r:id="rId10"/>
     <p:sldId id="260" r:id="rId11"/>
   </p:sldIdLst>
-  <p:sldSz cx="8229600" cy="14630400" type="screen4x3"/>
+  <p:sldSz cx="10287000" cy="18288000" type="screen4x3"/>
   <p:notesSz cx="6858000" cy="9144000"/>
   <p:defaultTextStyle>
     <a:defPPr>
@@ -3108,8 +3108,8 @@
         </p:nvSpPr>
         <p:spPr>
           <a:xfrm>
-            <a:off x="457200" y="5486400"/>
-            <a:ext cx="7315200" cy="3657600"/>
+            <a:off x="571500" y="6858000"/>
+            <a:ext cx="9144000" cy="4572000"/>
           </a:xfrm>
           <a:prstGeom prst="rect">
             <a:avLst/>
@@ -3124,7 +3124,7 @@
           <a:p>
             <a:pPr algn="ctr"/>
             <a:r>
-              <a:rPr sz="6600" b="1">
+              <a:rPr sz="8800" b="1">
                 <a:solidFill>
                   <a:srgbClr val="00F0FF"/>
                 </a:solidFill>
@@ -3134,7 +3134,7 @@
 </a:t>
             </a:r>
             <a:r>
-              <a:rPr sz="4100" b="1">
+              <a:rPr sz="5600" b="1">
                 <a:solidFill>
                   <a:srgbClr val="FFFFFF"/>
                 </a:solidFill>
@@ -3179,8 +3179,8 @@
         </p:nvSpPr>
         <p:spPr>
           <a:xfrm>
-            <a:off x="914400" y="4572000"/>
-            <a:ext cx="6400800" cy="5486400"/>
+            <a:off x="1143000" y="5715000"/>
+            <a:ext cx="8001000" cy="6858000"/>
           </a:xfrm>
           <a:prstGeom prst="rect">
             <a:avLst/>
@@ -3195,7 +3195,7 @@
           <a:p>
             <a:pPr algn="ctr"/>
             <a:r>
-              <a:rPr sz="4000" b="0">
+              <a:rPr sz="5000" b="0">
                 <a:solidFill>
                   <a:srgbClr val="FFFFFF"/>
                 </a:solidFill>
@@ -3207,7 +3207,7 @@
 </a:t>
             </a:r>
             <a:r>
-              <a:rPr sz="4600" b="1">
+              <a:rPr sz="6200" b="1">
                 <a:solidFill>
                   <a:srgbClr val="00F0FF"/>
                 </a:solidFill>
@@ -3217,7 +3217,7 @@
 </a:t>
             </a:r>
             <a:r>
-              <a:rPr sz="4000" b="0">
+              <a:rPr sz="5000" b="0">
                 <a:solidFill>
                   <a:srgbClr val="FFFFFF"/>
                 </a:solidFill>
@@ -3262,8 +3262,8 @@
         </p:nvSpPr>
         <p:spPr>
           <a:xfrm>
-            <a:off x="457200" y="1371600"/>
-            <a:ext cx="7315200" cy="11887200"/>
+            <a:off x="571500" y="1714500"/>
+            <a:ext cx="9144000" cy="14859000"/>
           </a:xfrm>
           <a:prstGeom prst="rect">
             <a:avLst/>
@@ -3277,7 +3277,7 @@
           <a:lstStyle/>
           <a:p>
             <a:r>
-              <a:rPr sz="5600" b="1">
+              <a:rPr sz="7500" b="1">
                 <a:solidFill>
                   <a:srgbClr val="00F0FF"/>
                 </a:solidFill>
@@ -3289,7 +3289,7 @@
           </a:p>
           <a:p>
             <a:r>
-              <a:rPr sz="2800" b="1">
+              <a:rPr sz="4000" b="1">
                 <a:solidFill>
                   <a:srgbClr val="00F0FF"/>
                 </a:solidFill>
@@ -3298,7 +3298,7 @@
               <a:t>Step 1 </a:t>
             </a:r>
             <a:r>
-              <a:rPr sz="2800" b="1">
+              <a:rPr sz="4000" b="1">
                 <a:solidFill>
                   <a:srgbClr val="FFFFFF"/>
                 </a:solidFill>
@@ -3309,7 +3309,7 @@
           </a:p>
           <a:p>
             <a:r>
-              <a:rPr sz="2800" b="0">
+              <a:rPr sz="3500" b="0">
                 <a:solidFill>
                   <a:srgbClr val="39FF14"/>
                 </a:solidFill>
@@ -3320,7 +3320,7 @@
           </a:p>
           <a:p>
             <a:r>
-              <a:rPr sz="2800" b="1">
+              <a:rPr sz="4000" b="1">
                 <a:solidFill>
                   <a:srgbClr val="00F0FF"/>
                 </a:solidFill>
@@ -3329,7 +3329,7 @@
               <a:t>Step 2 </a:t>
             </a:r>
             <a:r>
-              <a:rPr sz="2800" b="1">
+              <a:rPr sz="4000" b="1">
                 <a:solidFill>
                   <a:srgbClr val="FFFFFF"/>
                 </a:solidFill>
@@ -3340,7 +3340,7 @@
           </a:p>
           <a:p>
             <a:r>
-              <a:rPr sz="2800" b="0">
+              <a:rPr sz="3500" b="0">
                 <a:solidFill>
                   <a:srgbClr val="39FF14"/>
                 </a:solidFill>
@@ -3351,7 +3351,7 @@
           </a:p>
           <a:p>
             <a:r>
-              <a:rPr sz="2800" b="1">
+              <a:rPr sz="4000" b="1">
                 <a:solidFill>
                   <a:srgbClr val="00F0FF"/>
                 </a:solidFill>
@@ -3360,7 +3360,7 @@
               <a:t>Step 3 </a:t>
             </a:r>
             <a:r>
-              <a:rPr sz="2800" b="1">
+              <a:rPr sz="4000" b="1">
                 <a:solidFill>
                   <a:srgbClr val="FFFFFF"/>
                 </a:solidFill>
@@ -3371,7 +3371,7 @@
           </a:p>
           <a:p>
             <a:r>
-              <a:rPr sz="2800" b="0">
+              <a:rPr sz="3500" b="0">
                 <a:solidFill>
                   <a:srgbClr val="39FF14"/>
                 </a:solidFill>
@@ -3382,7 +3382,7 @@
           </a:p>
           <a:p>
             <a:r>
-              <a:rPr sz="2800" b="1">
+              <a:rPr sz="4000" b="1">
                 <a:solidFill>
                   <a:srgbClr val="00F0FF"/>
                 </a:solidFill>
@@ -3391,7 +3391,7 @@
               <a:t>Step 4 </a:t>
             </a:r>
             <a:r>
-              <a:rPr sz="2800" b="1">
+              <a:rPr sz="4000" b="1">
                 <a:solidFill>
                   <a:srgbClr val="FFFFFF"/>
                 </a:solidFill>
@@ -3402,7 +3402,7 @@
           </a:p>
           <a:p>
             <a:r>
-              <a:rPr sz="2800" b="0">
+              <a:rPr sz="3500" b="0">
                 <a:solidFill>
                   <a:srgbClr val="39FF14"/>
                 </a:solidFill>
@@ -3413,7 +3413,7 @@
           </a:p>
           <a:p>
             <a:r>
-              <a:rPr sz="2800" b="1">
+              <a:rPr sz="4000" b="1">
                 <a:solidFill>
                   <a:srgbClr val="00F0FF"/>
                 </a:solidFill>
@@ -3422,7 +3422,7 @@
               <a:t>Step 5 </a:t>
             </a:r>
             <a:r>
-              <a:rPr sz="2800" b="1">
+              <a:rPr sz="4000" b="1">
                 <a:solidFill>
                   <a:srgbClr val="FFFFFF"/>
                 </a:solidFill>
@@ -3433,7 +3433,7 @@
           </a:p>
           <a:p>
             <a:r>
-              <a:rPr sz="2800" b="0">
+              <a:rPr sz="3500" b="0">
                 <a:solidFill>
                   <a:srgbClr val="39FF14"/>
                 </a:solidFill>
@@ -3444,7 +3444,7 @@
           </a:p>
           <a:p>
             <a:r>
-              <a:rPr sz="2800" b="1">
+              <a:rPr sz="4000" b="1">
                 <a:solidFill>
                   <a:srgbClr val="00F0FF"/>
                 </a:solidFill>
@@ -3453,7 +3453,7 @@
               <a:t>Step 6 </a:t>
             </a:r>
             <a:r>
-              <a:rPr sz="2800" b="1">
+              <a:rPr sz="4000" b="1">
                 <a:solidFill>
                   <a:srgbClr val="FFFFFF"/>
                 </a:solidFill>
@@ -3464,7 +3464,7 @@
           </a:p>
           <a:p>
             <a:r>
-              <a:rPr sz="2800" b="0">
+              <a:rPr sz="3500" b="0">
                 <a:solidFill>
                   <a:srgbClr val="39FF14"/>
                 </a:solidFill>
@@ -3509,8 +3509,8 @@
         </p:nvSpPr>
         <p:spPr>
           <a:xfrm>
-            <a:off x="457200" y="4572000"/>
-            <a:ext cx="7315200" cy="5486400"/>
+            <a:off x="571500" y="5715000"/>
+            <a:ext cx="9144000" cy="6858000"/>
           </a:xfrm>
           <a:prstGeom prst="rect">
             <a:avLst/>
@@ -3525,7 +3525,7 @@
           <a:p>
             <a:pPr algn="ctr"/>
             <a:r>
-              <a:rPr sz="4100" b="1">
+              <a:rPr sz="5600" b="1">
                 <a:solidFill>
                   <a:srgbClr val="00F0FF"/>
                 </a:solidFill>
@@ -3539,7 +3539,7 @@
           <a:p>
             <a:pPr algn="ctr"/>
             <a:r>
-              <a:rPr sz="3500" b="0">
+              <a:rPr sz="4400" b="0">
                 <a:solidFill>
                   <a:srgbClr val="FFFFFF"/>
                 </a:solidFill>
@@ -3552,7 +3552,7 @@
           <a:p>
             <a:pPr algn="ctr"/>
             <a:r>
-              <a:rPr sz="3500" b="0">
+              <a:rPr sz="4400" b="0">
                 <a:solidFill>
                   <a:srgbClr val="FFFFFF"/>
                 </a:solidFill>
@@ -3565,7 +3565,7 @@
           <a:p>
             <a:pPr algn="ctr"/>
             <a:r>
-              <a:rPr sz="2800" b="1">
+              <a:rPr sz="4000" b="1">
                 <a:solidFill>
                   <a:srgbClr val="39FF14"/>
                 </a:solidFill>
@@ -3575,7 +3575,7 @@
 </a:t>
             </a:r>
             <a:r>
-              <a:rPr sz="3600" b="1">
+              <a:rPr sz="5000" b="1">
                 <a:solidFill>
                   <a:srgbClr val="00F0FF"/>
                 </a:solidFill>
@@ -3620,8 +3620,8 @@
         </p:nvSpPr>
         <p:spPr>
           <a:xfrm>
-            <a:off x="914400" y="5486400"/>
-            <a:ext cx="6400800" cy="3657600"/>
+            <a:off x="1143000" y="6858000"/>
+            <a:ext cx="8001000" cy="4572000"/>
           </a:xfrm>
           <a:prstGeom prst="rect">
             <a:avLst/>
@@ -3636,7 +3636,7 @@
           <a:p>
             <a:pPr algn="ctr"/>
             <a:r>
-              <a:rPr sz="4600" b="1">
+              <a:rPr sz="6200" b="1">
                 <a:solidFill>
                   <a:srgbClr val="FFFFFF"/>
                 </a:solidFill>
@@ -3648,7 +3648,7 @@
 </a:t>
             </a:r>
             <a:r>
-              <a:rPr sz="4100" b="1">
+              <a:rPr sz="5600" b="1">
                 <a:solidFill>
                   <a:srgbClr val="39FF14"/>
                 </a:solidFill>

</xml_diff>

<commit_message>
auto: Cowork/CLI 동기화 2026-07-17 15:11
</commit_message>
<xml_diff>
--- a/63_youtube_creator/pipeline/output/crisp_dm_shorts.pptx
+++ b/63_youtube_creator/pipeline/output/crisp_dm_shorts.pptx
@@ -3102,7 +3102,7 @@
       <p:grpSpPr/>
       <p:sp>
         <p:nvSpPr>
-          <p:cNvPr id="2" name="TextBox 1"/>
+          <p:cNvPr id="2" name="title_1"/>
           <p:cNvSpPr txBox="1"/>
           <p:nvPr/>
         </p:nvSpPr>
@@ -3173,7 +3173,7 @@
       <p:grpSpPr/>
       <p:sp>
         <p:nvSpPr>
-          <p:cNvPr id="2" name="TextBox 1"/>
+          <p:cNvPr id="2" name="body_2"/>
           <p:cNvSpPr txBox="1"/>
           <p:nvPr/>
         </p:nvSpPr>
@@ -3256,7 +3256,7 @@
       <p:grpSpPr/>
       <p:sp>
         <p:nvSpPr>
-          <p:cNvPr id="2" name="TextBox 1"/>
+          <p:cNvPr id="2" name="body_3"/>
           <p:cNvSpPr txBox="1"/>
           <p:nvPr/>
         </p:nvSpPr>
@@ -3503,7 +3503,7 @@
       <p:grpSpPr/>
       <p:sp>
         <p:nvSpPr>
-          <p:cNvPr id="2" name="TextBox 1"/>
+          <p:cNvPr id="2" name="body_4"/>
           <p:cNvSpPr txBox="1"/>
           <p:nvPr/>
         </p:nvSpPr>
@@ -3614,7 +3614,7 @@
       <p:grpSpPr/>
       <p:sp>
         <p:nvSpPr>
-          <p:cNvPr id="2" name="TextBox 1"/>
+          <p:cNvPr id="2" name="title_5"/>
           <p:cNvSpPr txBox="1"/>
           <p:nvPr/>
         </p:nvSpPr>

</xml_diff>

<commit_message>
auto: Cowork/CLI 동기화 2026-07-17 15:13
</commit_message>
<xml_diff>
--- a/63_youtube_creator/pipeline/output/crisp_dm_shorts.pptx
+++ b/63_youtube_creator/pipeline/output/crisp_dm_shorts.pptx
@@ -3646,15 +3646,6 @@
 무조건 알아야 할
 데이터 분석 기초!
 </a:t>
-            </a:r>
-            <a:r>
-              <a:rPr sz="5600" b="1">
-                <a:solidFill>
-                  <a:srgbClr val="39FF14"/>
-                </a:solidFill>
-                <a:latin typeface="Malgun Gothic"/>
-              </a:rPr>
-              <a:t>구독 &amp; 좋아요 🤍</a:t>
             </a:r>
           </a:p>
         </p:txBody>

</xml_diff>